<commit_message>
Update ERS decks for Kova, AGENTS.md and the checkpoint schedule
Decks 01, 03 and 04 state the checkpoint requirements and dates from the
portal checkpoint list. Decks 06, 07 and 08 describe the Kova workflow, name
AGENTS.md as the project rules file and quote the current example code. PDFs
are re-exported from the updated PPTX sources.
</commit_message>
<xml_diff>
--- a/01 Elementi Razvoja Softvera/02 Prezentacije/PPTX/01_Zahtevi_backlog_i_Git.pptx
+++ b/01 Elementi Razvoja Softvera/02 Prezentacije/PPTX/01_Zahtevi_backlog_i_Git.pptx
@@ -9757,7 +9757,7 @@
                 <a:ea typeface="Aptos"/>
                 <a:cs typeface="Aptos"/>
               </a:rPr>
-              <a:t>Провера обухвата следљив процес, основну структуру репозиторијума и почетни backlog.</a:t>
+              <a:t>После Вежбе 2, недеља од 19.10: проблем, backlog и развојни ток у репозиторијуму.</a:t>
             </a:r>
           </a:p>
         </p:txBody>
@@ -9982,7 +9982,7 @@
                 <a:ea typeface="Aptos"/>
                 <a:cs typeface="Aptos"/>
               </a:rPr>
-              <a:t>заједнички репозиторијум и основни опис</a:t>
+              <a:t>README и приступ свих чланова тима</a:t>
             </a:r>
           </a:p>
         </p:txBody>
@@ -10151,7 +10151,7 @@
                 <a:ea typeface="Aptos"/>
                 <a:cs typeface="Aptos"/>
               </a:rPr>
-              <a:t>Почетни backlog</a:t>
+              <a:t>Backlog у Tapiz Boards</a:t>
             </a:r>
           </a:p>
         </p:txBody>
@@ -10207,7 +10207,7 @@
                 <a:ea typeface="Aptos"/>
                 <a:cs typeface="Aptos"/>
               </a:rPr>
-              <a:t>јасне ставке и приоритети</a:t>
+              <a:t>приоритети и критеријуми прихватања</a:t>
             </a:r>
           </a:p>
         </p:txBody>
@@ -10376,7 +10376,7 @@
                 <a:ea typeface="Aptos"/>
                 <a:cs typeface="Aptos"/>
               </a:rPr>
-              <a:t>Грана или PR</a:t>
+              <a:t>Pull request</a:t>
             </a:r>
           </a:p>
         </p:txBody>
@@ -10432,7 +10432,7 @@
                 <a:ea typeface="Aptos"/>
                 <a:cs typeface="Aptos"/>
               </a:rPr>
-              <a:t>ставка повезана са конкретним радом</a:t>
+              <a:t>преглед измена и образложени коментари</a:t>
             </a:r>
           </a:p>
         </p:txBody>
@@ -10601,7 +10601,7 @@
                 <a:ea typeface="Aptos"/>
                 <a:cs typeface="Aptos"/>
               </a:rPr>
-              <a:t>Докази провере</a:t>
+              <a:t>Договорени ток</a:t>
             </a:r>
           </a:p>
         </p:txBody>
@@ -10657,7 +10657,7 @@
                 <a:ea typeface="Aptos"/>
                 <a:cs typeface="Aptos"/>
               </a:rPr>
-              <a:t>тим уме да објасни шта је урађено</a:t>
+              <a:t>од Backlog до Done, кроз Review и QA</a:t>
             </a:r>
           </a:p>
         </p:txBody>

</xml_diff>